<commit_message>
Omit the pdf Producer and the Aspose.Slides environment tags from snapshots
The Producer names the library and version that wrote the pdf, so it changes whenever that library is upgraded rather than when the document does. Aspose.Slides likewise stamps a saved pptx with AS_* tags naming its version and the machine's .NET and OS versions, so those are removed from the pptx snapshot.
</commit_message>
<xml_diff>
--- a/src/Tests/Samples.VerifyPowerPoint.verified.pptx
+++ b/src/Tests/Samples.VerifyPowerPoint.verified.pptx
@@ -32639,13 +32639,7 @@
 </file>
 
 <file path=ppt/tags/tag1.xml><?xml version="1.0" encoding="utf-8"?>
-<p:tagLst xmlns:p="http://schemas.openxmlformats.org/presentationml/2006/main">
-  <p:tag name="AS_NET" val="10.0.12"/>
-  <p:tag name="AS_OS" val="Microsoft Windows NT 10.0.28000.0"/>
-  <p:tag name="AS_RELEASE_DATE" val="2026.10.14"/>
-  <p:tag name="AS_TITLE" val="Aspose.Slides for .NET6"/>
-  <p:tag name="AS_VERSION" val="26.10"/>
-</p:tagLst>
+<p:tagLst xmlns:p="http://schemas.openxmlformats.org/presentationml/2006/main"/>
 </file>
 
 <file path=ppt/theme/theme1.xml><?xml version="1.0" encoding="utf-8"?>

</xml_diff>

<commit_message>
Omit the pdf Producer and the Aspose.Slides environment tags from snapshots (#991)
* Omit the pdf Producer and the Aspose.Slides environment tags from snapshots

The Producer names the library and version that wrote the pdf, so it changes whenever that library is upgraded rather than when the document does. Aspose.Slides likewise stamps a saved pptx with AS_* tags naming its version and the machine's .NET and OS versions, so those are removed from the pptx snapshot.

* Bump DeterministicPdf to 2.3.0

2.3.0 removes the Producer from the pdf snapshot too, so it no longer changes with the library that wrote the document, and repairs offsets in cross-reference streams and incremental updates, so documents of those shapes are now fully normalized. Each changed .verified.pdf is exactly what 2.3.0 produces from the previous one.
</commit_message>
<xml_diff>
--- a/src/Tests/Samples.VerifyPowerPoint.verified.pptx
+++ b/src/Tests/Samples.VerifyPowerPoint.verified.pptx
@@ -32639,13 +32639,7 @@
 </file>
 
 <file path=ppt/tags/tag1.xml><?xml version="1.0" encoding="utf-8"?>
-<p:tagLst xmlns:p="http://schemas.openxmlformats.org/presentationml/2006/main">
-  <p:tag name="AS_NET" val="10.0.12"/>
-  <p:tag name="AS_OS" val="Microsoft Windows NT 10.0.28000.0"/>
-  <p:tag name="AS_RELEASE_DATE" val="2026.10.14"/>
-  <p:tag name="AS_TITLE" val="Aspose.Slides for .NET6"/>
-  <p:tag name="AS_VERSION" val="26.10"/>
-</p:tagLst>
+<p:tagLst xmlns:p="http://schemas.openxmlformats.org/presentationml/2006/main"/>
 </file>
 
 <file path=ppt/theme/theme1.xml><?xml version="1.0" encoding="utf-8"?>

</xml_diff>